<commit_message>
docs: update report and pitch deck to feature interactive chatbot
</commit_message>
<xml_diff>
--- a/docs/OmniSight_Pitch_Deck.pptx
+++ b/docs/OmniSight_Pitch_Deck.pptx
@@ -3550,7 +3550,7 @@
             </a:r>
             <a:r>
               <a:rPr/>
-              <a:t> - Clean, high-contrast screenshot of the OmniSight Dashboard (Dark Mode). - Three floating badges: 1. ⚡️ Instant Aggregation 2. 🧠 Agentic AI Synthesis 3. 📈 Predictive Roadmaps</a:t>
+              <a:t> - Clean, high-contrast screenshot of the OmniSight Dashboard (Dark Mode). - Three floating badges: 1. ⚡️ Instant Aggregation 2. 🧠 Agentic AI Synthesis 3. 🗣️ Interactive AI Chat</a:t>
             </a:r>
           </a:p>
           <a:p>
@@ -3571,7 +3571,7 @@
             </a:r>
             <a:r>
               <a:rPr/>
-              <a:t> it and builds a strategy for you.”</a:t>
+              <a:t> it, builds a strategy for you, and allows you to chat with the data in real-time.”</a:t>
             </a:r>
           </a:p>
         </p:txBody>
@@ -3813,7 +3813,7 @@
             </a:pPr>
             <a:r>
               <a:rPr b="1"/>
-              <a:t>Slide 6: Product Demo - The Dashboard</a:t>
+              <a:t>Slide 6: Product Demo - The Dashboard &amp; Interactive Agent</a:t>
             </a:r>
           </a:p>
           <a:p>
@@ -3838,21 +3838,11 @@
             </a:r>
             <a:r>
               <a:rPr b="1"/>
-              <a:t>Interactive SEO Threat Web</a:t>
+              <a:t>Interactive Live Agent Sidebar</a:t>
             </a:r>
             <a:r>
               <a:rPr/>
-              <a:t>. - Highlight the </a:t>
-            </a:r>
-            <a:r>
-              <a:rPr>
-                <a:latin typeface="Courier"/>
-              </a:rPr>
-              <a:t>ReactFlow</a:t>
-            </a:r>
-            <a:r>
-              <a:rPr/>
-              <a:t> graph.</a:t>
+              <a:t>.</a:t>
             </a:r>
           </a:p>
           <a:p>
@@ -3865,7 +3855,7 @@
             </a:r>
             <a:r>
               <a:rPr/>
-              <a:t> &gt; “Let’s look at the product. The dashboard instantly generates an Interactive SEO Threat Web—a visual mind-map built from live ‘People Also Ask’ data. Click any node, and OmniSight simulates enterprise metrics like Keyword Difficulty and CPC, allowing you to bypass saturated head-keywords and target lucrative long-tail gaps.”</a:t>
+              <a:t> &gt; “Let’s look at the product. The dashboard instantly generates an Interactive SEO Threat Web based on live consumer intent. But the magic happens in our Live Agent Sidebar. Not only does it stream news and calculate arbitrage, it features a fully interactive conversational AI. You can literally chat with the market data, asking the agent to clarify specific pricing gaps or SEO strategies in real-time.”</a:t>
             </a:r>
           </a:p>
         </p:txBody>
@@ -3941,7 +3931,7 @@
             </a:r>
             <a:r>
               <a:rPr/>
-              <a:t> &gt; “And here is our crown jewel: The Autonomous AI Blueprint. Because we enforced strict JSON generation, Gemini actually writes the content for this beautiful tabbed interface. It tells you exactly what’s going well, what needs attention, and gives you a 12-month execution phase plan—all based entirely on the live search data pulled milliseconds prior.”</a:t>
+              <a:t> &gt; “And here is our crown jewel: The Autonomous AI Blueprint. Because we enforced strict JSON generation, Gemini writes the content for this beautiful tabbed interface. It tells you exactly what’s going well, what needs attention, and gives you a 12-month execution phase plan—and if you want the mathematical rationale behind any recommendation, you can click the deep-dive button to reveal exactly how it lowered your Customer Acquisition Cost.”</a:t>
             </a:r>
           </a:p>
         </p:txBody>

</xml_diff>